<commit_message>
Update P5 STEAM tasting-course lesson slides.
Co-authored-by: Cursor <cursoragent@cursor.com>
</commit_message>
<xml_diff>
--- a/Subjects/STEAM/tasting-course/docs/handouts/lesson-slides.pptx
+++ b/Subjects/STEAM/tasting-course/docs/handouts/lesson-slides.pptx
@@ -5,25 +5,25 @@
     <p:sldMasterId id="2147483648" r:id="rId1"/>
   </p:sldMasterIdLst>
   <p:sldIdLst>
-    <p:sldId id="256" r:id="rId7"/>
-    <p:sldId id="257" r:id="rId8"/>
-    <p:sldId id="258" r:id="rId9"/>
-    <p:sldId id="259" r:id="rId10"/>
-    <p:sldId id="260" r:id="rId11"/>
-    <p:sldId id="261" r:id="rId12"/>
-    <p:sldId id="262" r:id="rId13"/>
-    <p:sldId id="263" r:id="rId14"/>
-    <p:sldId id="264" r:id="rId15"/>
-    <p:sldId id="265" r:id="rId16"/>
-    <p:sldId id="266" r:id="rId17"/>
-    <p:sldId id="267" r:id="rId18"/>
-    <p:sldId id="268" r:id="rId19"/>
-    <p:sldId id="269" r:id="rId20"/>
-    <p:sldId id="270" r:id="rId21"/>
-    <p:sldId id="271" r:id="rId22"/>
-    <p:sldId id="272" r:id="rId23"/>
+    <p:sldId id="256" r:id="rId2"/>
+    <p:sldId id="257" r:id="rId3"/>
+    <p:sldId id="258" r:id="rId4"/>
+    <p:sldId id="259" r:id="rId5"/>
+    <p:sldId id="260" r:id="rId6"/>
+    <p:sldId id="261" r:id="rId7"/>
+    <p:sldId id="262" r:id="rId8"/>
+    <p:sldId id="263" r:id="rId9"/>
+    <p:sldId id="264" r:id="rId10"/>
+    <p:sldId id="265" r:id="rId11"/>
+    <p:sldId id="266" r:id="rId12"/>
+    <p:sldId id="267" r:id="rId13"/>
+    <p:sldId id="268" r:id="rId14"/>
+    <p:sldId id="269" r:id="rId15"/>
+    <p:sldId id="270" r:id="rId16"/>
+    <p:sldId id="271" r:id="rId17"/>
+    <p:sldId id="272" r:id="rId18"/>
   </p:sldIdLst>
-  <p:sldSz cx="12188952" cy="6858000" type="screen4x3"/>
+  <p:sldSz cx="12188825" cy="6858000"/>
   <p:notesSz cx="6858000" cy="9144000"/>
   <p:defaultTextStyle>
     <a:defPPr>
@@ -120,6 +120,22 @@
       </a:defRPr>
     </a:lvl9pPr>
   </p:defaultTextStyle>
+  <p:extLst>
+    <p:ext uri="{EFAFB233-063F-42B5-8137-9DF3F51BA10A}">
+      <p15:sldGuideLst xmlns:p15="http://schemas.microsoft.com/office/powerpoint/2012/main">
+        <p15:guide id="1" orient="horz" pos="2160">
+          <p15:clr>
+            <a:srgbClr val="A4A3A4"/>
+          </p15:clr>
+        </p15:guide>
+        <p15:guide id="2" pos="2880">
+          <p15:clr>
+            <a:srgbClr val="A4A3A4"/>
+          </p15:clr>
+        </p15:guide>
+      </p15:sldGuideLst>
+    </p:ext>
+  </p:extLst>
 </p:presentation>
 </file>
 
@@ -161,10 +177,9 @@
           <a:lstStyle/>
           <a:p>
             <a:r>
-              <a:rPr lang="en-US" smtClean="0"/>
+              <a:rPr lang="en-US"/>
               <a:t>Click to edit Master title style</a:t>
             </a:r>
-            <a:endParaRPr lang="en-US"/>
           </a:p>
         </p:txBody>
       </p:sp>
@@ -280,10 +295,9 @@
           </a:lstStyle>
           <a:p>
             <a:r>
-              <a:rPr lang="en-US" smtClean="0"/>
+              <a:rPr lang="en-US"/>
               <a:t>Click to edit Master subtitle style</a:t>
             </a:r>
-            <a:endParaRPr lang="en-US"/>
           </a:p>
         </p:txBody>
       </p:sp>
@@ -304,7 +318,7 @@
           <a:p>
             <a:fld id="{5BCAD085-E8A6-8845-BD4E-CB4CCA059FC4}" type="datetimeFigureOut">
               <a:rPr lang="en-US" smtClean="0"/>
-              <a:t>1/27/13</a:t>
+              <a:t>6/30/26</a:t>
             </a:fld>
             <a:endParaRPr lang="en-US"/>
           </a:p>
@@ -398,10 +412,9 @@
           <a:lstStyle/>
           <a:p>
             <a:r>
-              <a:rPr lang="en-US" smtClean="0"/>
+              <a:rPr lang="en-US"/>
               <a:t>Click to edit Master title style</a:t>
             </a:r>
-            <a:endParaRPr lang="en-US"/>
           </a:p>
         </p:txBody>
       </p:sp>
@@ -422,38 +435,37 @@
           <a:p>
             <a:pPr lvl="0"/>
             <a:r>
-              <a:rPr lang="en-US" smtClean="0"/>
+              <a:rPr lang="en-US"/>
               <a:t>Click to edit Master text styles</a:t>
             </a:r>
           </a:p>
           <a:p>
             <a:pPr lvl="1"/>
             <a:r>
-              <a:rPr lang="en-US" smtClean="0"/>
+              <a:rPr lang="en-US"/>
               <a:t>Second level</a:t>
             </a:r>
           </a:p>
           <a:p>
             <a:pPr lvl="2"/>
             <a:r>
-              <a:rPr lang="en-US" smtClean="0"/>
+              <a:rPr lang="en-US"/>
               <a:t>Third level</a:t>
             </a:r>
           </a:p>
           <a:p>
             <a:pPr lvl="3"/>
             <a:r>
-              <a:rPr lang="en-US" smtClean="0"/>
+              <a:rPr lang="en-US"/>
               <a:t>Fourth level</a:t>
             </a:r>
           </a:p>
           <a:p>
             <a:pPr lvl="4"/>
             <a:r>
-              <a:rPr lang="en-US" smtClean="0"/>
+              <a:rPr lang="en-US"/>
               <a:t>Fifth level</a:t>
             </a:r>
-            <a:endParaRPr lang="en-US"/>
           </a:p>
         </p:txBody>
       </p:sp>
@@ -474,7 +486,7 @@
           <a:p>
             <a:fld id="{5BCAD085-E8A6-8845-BD4E-CB4CCA059FC4}" type="datetimeFigureOut">
               <a:rPr lang="en-US" smtClean="0"/>
-              <a:t>1/27/13</a:t>
+              <a:t>6/30/26</a:t>
             </a:fld>
             <a:endParaRPr lang="en-US"/>
           </a:p>
@@ -573,10 +585,9 @@
           <a:lstStyle/>
           <a:p>
             <a:r>
-              <a:rPr lang="en-US" smtClean="0"/>
+              <a:rPr lang="en-US"/>
               <a:t>Click to edit Master title style</a:t>
             </a:r>
-            <a:endParaRPr lang="en-US"/>
           </a:p>
         </p:txBody>
       </p:sp>
@@ -602,38 +613,37 @@
           <a:p>
             <a:pPr lvl="0"/>
             <a:r>
-              <a:rPr lang="en-US" smtClean="0"/>
+              <a:rPr lang="en-US"/>
               <a:t>Click to edit Master text styles</a:t>
             </a:r>
           </a:p>
           <a:p>
             <a:pPr lvl="1"/>
             <a:r>
-              <a:rPr lang="en-US" smtClean="0"/>
+              <a:rPr lang="en-US"/>
               <a:t>Second level</a:t>
             </a:r>
           </a:p>
           <a:p>
             <a:pPr lvl="2"/>
             <a:r>
-              <a:rPr lang="en-US" smtClean="0"/>
+              <a:rPr lang="en-US"/>
               <a:t>Third level</a:t>
             </a:r>
           </a:p>
           <a:p>
             <a:pPr lvl="3"/>
             <a:r>
-              <a:rPr lang="en-US" smtClean="0"/>
+              <a:rPr lang="en-US"/>
               <a:t>Fourth level</a:t>
             </a:r>
           </a:p>
           <a:p>
             <a:pPr lvl="4"/>
             <a:r>
-              <a:rPr lang="en-US" smtClean="0"/>
+              <a:rPr lang="en-US"/>
               <a:t>Fifth level</a:t>
             </a:r>
-            <a:endParaRPr lang="en-US"/>
           </a:p>
         </p:txBody>
       </p:sp>
@@ -654,7 +664,7 @@
           <a:p>
             <a:fld id="{5BCAD085-E8A6-8845-BD4E-CB4CCA059FC4}" type="datetimeFigureOut">
               <a:rPr lang="en-US" smtClean="0"/>
-              <a:t>1/27/13</a:t>
+              <a:t>6/30/26</a:t>
             </a:fld>
             <a:endParaRPr lang="en-US"/>
           </a:p>
@@ -748,10 +758,9 @@
           <a:lstStyle/>
           <a:p>
             <a:r>
-              <a:rPr lang="en-US" smtClean="0"/>
+              <a:rPr lang="en-US"/>
               <a:t>Click to edit Master title style</a:t>
             </a:r>
-            <a:endParaRPr lang="en-US"/>
           </a:p>
         </p:txBody>
       </p:sp>
@@ -772,38 +781,37 @@
           <a:p>
             <a:pPr lvl="0"/>
             <a:r>
-              <a:rPr lang="en-US" smtClean="0"/>
+              <a:rPr lang="en-US"/>
               <a:t>Click to edit Master text styles</a:t>
             </a:r>
           </a:p>
           <a:p>
             <a:pPr lvl="1"/>
             <a:r>
-              <a:rPr lang="en-US" smtClean="0"/>
+              <a:rPr lang="en-US"/>
               <a:t>Second level</a:t>
             </a:r>
           </a:p>
           <a:p>
             <a:pPr lvl="2"/>
             <a:r>
-              <a:rPr lang="en-US" smtClean="0"/>
+              <a:rPr lang="en-US"/>
               <a:t>Third level</a:t>
             </a:r>
           </a:p>
           <a:p>
             <a:pPr lvl="3"/>
             <a:r>
-              <a:rPr lang="en-US" smtClean="0"/>
+              <a:rPr lang="en-US"/>
               <a:t>Fourth level</a:t>
             </a:r>
           </a:p>
           <a:p>
             <a:pPr lvl="4"/>
             <a:r>
-              <a:rPr lang="en-US" smtClean="0"/>
+              <a:rPr lang="en-US"/>
               <a:t>Fifth level</a:t>
             </a:r>
-            <a:endParaRPr lang="en-US"/>
           </a:p>
         </p:txBody>
       </p:sp>
@@ -824,7 +832,7 @@
           <a:p>
             <a:fld id="{5BCAD085-E8A6-8845-BD4E-CB4CCA059FC4}" type="datetimeFigureOut">
               <a:rPr lang="en-US" smtClean="0"/>
-              <a:t>1/27/13</a:t>
+              <a:t>6/30/26</a:t>
             </a:fld>
             <a:endParaRPr lang="en-US"/>
           </a:p>
@@ -927,10 +935,9 @@
           </a:lstStyle>
           <a:p>
             <a:r>
-              <a:rPr lang="en-US" smtClean="0"/>
+              <a:rPr lang="en-US"/>
               <a:t>Click to edit Master title style</a:t>
             </a:r>
-            <a:endParaRPr lang="en-US"/>
           </a:p>
         </p:txBody>
       </p:sp>
@@ -1047,7 +1054,7 @@
           <a:p>
             <a:pPr lvl="0"/>
             <a:r>
-              <a:rPr lang="en-US" smtClean="0"/>
+              <a:rPr lang="en-US"/>
               <a:t>Click to edit Master text styles</a:t>
             </a:r>
           </a:p>
@@ -1070,7 +1077,7 @@
           <a:p>
             <a:fld id="{5BCAD085-E8A6-8845-BD4E-CB4CCA059FC4}" type="datetimeFigureOut">
               <a:rPr lang="en-US" smtClean="0"/>
-              <a:t>1/27/13</a:t>
+              <a:t>6/30/26</a:t>
             </a:fld>
             <a:endParaRPr lang="en-US"/>
           </a:p>
@@ -1164,10 +1171,9 @@
           <a:lstStyle/>
           <a:p>
             <a:r>
-              <a:rPr lang="en-US" smtClean="0"/>
+              <a:rPr lang="en-US"/>
               <a:t>Click to edit Master title style</a:t>
             </a:r>
-            <a:endParaRPr lang="en-US"/>
           </a:p>
         </p:txBody>
       </p:sp>
@@ -1221,38 +1227,37 @@
           <a:p>
             <a:pPr lvl="0"/>
             <a:r>
-              <a:rPr lang="en-US" smtClean="0"/>
+              <a:rPr lang="en-US"/>
               <a:t>Click to edit Master text styles</a:t>
             </a:r>
           </a:p>
           <a:p>
             <a:pPr lvl="1"/>
             <a:r>
-              <a:rPr lang="en-US" smtClean="0"/>
+              <a:rPr lang="en-US"/>
               <a:t>Second level</a:t>
             </a:r>
           </a:p>
           <a:p>
             <a:pPr lvl="2"/>
             <a:r>
-              <a:rPr lang="en-US" smtClean="0"/>
+              <a:rPr lang="en-US"/>
               <a:t>Third level</a:t>
             </a:r>
           </a:p>
           <a:p>
             <a:pPr lvl="3"/>
             <a:r>
-              <a:rPr lang="en-US" smtClean="0"/>
+              <a:rPr lang="en-US"/>
               <a:t>Fourth level</a:t>
             </a:r>
           </a:p>
           <a:p>
             <a:pPr lvl="4"/>
             <a:r>
-              <a:rPr lang="en-US" smtClean="0"/>
+              <a:rPr lang="en-US"/>
               <a:t>Fifth level</a:t>
             </a:r>
-            <a:endParaRPr lang="en-US"/>
           </a:p>
         </p:txBody>
       </p:sp>
@@ -1306,38 +1311,37 @@
           <a:p>
             <a:pPr lvl="0"/>
             <a:r>
-              <a:rPr lang="en-US" smtClean="0"/>
+              <a:rPr lang="en-US"/>
               <a:t>Click to edit Master text styles</a:t>
             </a:r>
           </a:p>
           <a:p>
             <a:pPr lvl="1"/>
             <a:r>
-              <a:rPr lang="en-US" smtClean="0"/>
+              <a:rPr lang="en-US"/>
               <a:t>Second level</a:t>
             </a:r>
           </a:p>
           <a:p>
             <a:pPr lvl="2"/>
             <a:r>
-              <a:rPr lang="en-US" smtClean="0"/>
+              <a:rPr lang="en-US"/>
               <a:t>Third level</a:t>
             </a:r>
           </a:p>
           <a:p>
             <a:pPr lvl="3"/>
             <a:r>
-              <a:rPr lang="en-US" smtClean="0"/>
+              <a:rPr lang="en-US"/>
               <a:t>Fourth level</a:t>
             </a:r>
           </a:p>
           <a:p>
             <a:pPr lvl="4"/>
             <a:r>
-              <a:rPr lang="en-US" smtClean="0"/>
+              <a:rPr lang="en-US"/>
               <a:t>Fifth level</a:t>
             </a:r>
-            <a:endParaRPr lang="en-US"/>
           </a:p>
         </p:txBody>
       </p:sp>
@@ -1358,7 +1362,7 @@
           <a:p>
             <a:fld id="{5BCAD085-E8A6-8845-BD4E-CB4CCA059FC4}" type="datetimeFigureOut">
               <a:rPr lang="en-US" smtClean="0"/>
-              <a:t>1/27/13</a:t>
+              <a:t>6/30/26</a:t>
             </a:fld>
             <a:endParaRPr lang="en-US"/>
           </a:p>
@@ -1456,10 +1460,9 @@
           </a:lstStyle>
           <a:p>
             <a:r>
-              <a:rPr lang="en-US" smtClean="0"/>
+              <a:rPr lang="en-US"/>
               <a:t>Click to edit Master title style</a:t>
             </a:r>
-            <a:endParaRPr lang="en-US"/>
           </a:p>
         </p:txBody>
       </p:sp>
@@ -1522,7 +1525,7 @@
           <a:p>
             <a:pPr lvl="0"/>
             <a:r>
-              <a:rPr lang="en-US" smtClean="0"/>
+              <a:rPr lang="en-US"/>
               <a:t>Click to edit Master text styles</a:t>
             </a:r>
           </a:p>
@@ -1578,38 +1581,37 @@
           <a:p>
             <a:pPr lvl="0"/>
             <a:r>
-              <a:rPr lang="en-US" smtClean="0"/>
+              <a:rPr lang="en-US"/>
               <a:t>Click to edit Master text styles</a:t>
             </a:r>
           </a:p>
           <a:p>
             <a:pPr lvl="1"/>
             <a:r>
-              <a:rPr lang="en-US" smtClean="0"/>
+              <a:rPr lang="en-US"/>
               <a:t>Second level</a:t>
             </a:r>
           </a:p>
           <a:p>
             <a:pPr lvl="2"/>
             <a:r>
-              <a:rPr lang="en-US" smtClean="0"/>
+              <a:rPr lang="en-US"/>
               <a:t>Third level</a:t>
             </a:r>
           </a:p>
           <a:p>
             <a:pPr lvl="3"/>
             <a:r>
-              <a:rPr lang="en-US" smtClean="0"/>
+              <a:rPr lang="en-US"/>
               <a:t>Fourth level</a:t>
             </a:r>
           </a:p>
           <a:p>
             <a:pPr lvl="4"/>
             <a:r>
-              <a:rPr lang="en-US" smtClean="0"/>
+              <a:rPr lang="en-US"/>
               <a:t>Fifth level</a:t>
             </a:r>
-            <a:endParaRPr lang="en-US"/>
           </a:p>
         </p:txBody>
       </p:sp>
@@ -1672,7 +1674,7 @@
           <a:p>
             <a:pPr lvl="0"/>
             <a:r>
-              <a:rPr lang="en-US" smtClean="0"/>
+              <a:rPr lang="en-US"/>
               <a:t>Click to edit Master text styles</a:t>
             </a:r>
           </a:p>
@@ -1728,38 +1730,37 @@
           <a:p>
             <a:pPr lvl="0"/>
             <a:r>
-              <a:rPr lang="en-US" smtClean="0"/>
+              <a:rPr lang="en-US"/>
               <a:t>Click to edit Master text styles</a:t>
             </a:r>
           </a:p>
           <a:p>
             <a:pPr lvl="1"/>
             <a:r>
-              <a:rPr lang="en-US" smtClean="0"/>
+              <a:rPr lang="en-US"/>
               <a:t>Second level</a:t>
             </a:r>
           </a:p>
           <a:p>
             <a:pPr lvl="2"/>
             <a:r>
-              <a:rPr lang="en-US" smtClean="0"/>
+              <a:rPr lang="en-US"/>
               <a:t>Third level</a:t>
             </a:r>
           </a:p>
           <a:p>
             <a:pPr lvl="3"/>
             <a:r>
-              <a:rPr lang="en-US" smtClean="0"/>
+              <a:rPr lang="en-US"/>
               <a:t>Fourth level</a:t>
             </a:r>
           </a:p>
           <a:p>
             <a:pPr lvl="4"/>
             <a:r>
-              <a:rPr lang="en-US" smtClean="0"/>
+              <a:rPr lang="en-US"/>
               <a:t>Fifth level</a:t>
             </a:r>
-            <a:endParaRPr lang="en-US"/>
           </a:p>
         </p:txBody>
       </p:sp>
@@ -1780,7 +1781,7 @@
           <a:p>
             <a:fld id="{5BCAD085-E8A6-8845-BD4E-CB4CCA059FC4}" type="datetimeFigureOut">
               <a:rPr lang="en-US" smtClean="0"/>
-              <a:t>1/27/13</a:t>
+              <a:t>6/30/26</a:t>
             </a:fld>
             <a:endParaRPr lang="en-US"/>
           </a:p>
@@ -1874,10 +1875,9 @@
           <a:lstStyle/>
           <a:p>
             <a:r>
-              <a:rPr lang="en-US" smtClean="0"/>
+              <a:rPr lang="en-US"/>
               <a:t>Click to edit Master title style</a:t>
             </a:r>
-            <a:endParaRPr lang="en-US"/>
           </a:p>
         </p:txBody>
       </p:sp>
@@ -1898,7 +1898,7 @@
           <a:p>
             <a:fld id="{5BCAD085-E8A6-8845-BD4E-CB4CCA059FC4}" type="datetimeFigureOut">
               <a:rPr lang="en-US" smtClean="0"/>
-              <a:t>1/27/13</a:t>
+              <a:t>6/30/26</a:t>
             </a:fld>
             <a:endParaRPr lang="en-US"/>
           </a:p>
@@ -1993,7 +1993,7 @@
           <a:p>
             <a:fld id="{5BCAD085-E8A6-8845-BD4E-CB4CCA059FC4}" type="datetimeFigureOut">
               <a:rPr lang="en-US" smtClean="0"/>
-              <a:t>1/27/13</a:t>
+              <a:t>6/30/26</a:t>
             </a:fld>
             <a:endParaRPr lang="en-US"/>
           </a:p>
@@ -2096,10 +2096,9 @@
           </a:lstStyle>
           <a:p>
             <a:r>
-              <a:rPr lang="en-US" smtClean="0"/>
+              <a:rPr lang="en-US"/>
               <a:t>Click to edit Master title style</a:t>
             </a:r>
-            <a:endParaRPr lang="en-US"/>
           </a:p>
         </p:txBody>
       </p:sp>
@@ -2153,38 +2152,37 @@
           <a:p>
             <a:pPr lvl="0"/>
             <a:r>
-              <a:rPr lang="en-US" smtClean="0"/>
+              <a:rPr lang="en-US"/>
               <a:t>Click to edit Master text styles</a:t>
             </a:r>
           </a:p>
           <a:p>
             <a:pPr lvl="1"/>
             <a:r>
-              <a:rPr lang="en-US" smtClean="0"/>
+              <a:rPr lang="en-US"/>
               <a:t>Second level</a:t>
             </a:r>
           </a:p>
           <a:p>
             <a:pPr lvl="2"/>
             <a:r>
-              <a:rPr lang="en-US" smtClean="0"/>
+              <a:rPr lang="en-US"/>
               <a:t>Third level</a:t>
             </a:r>
           </a:p>
           <a:p>
             <a:pPr lvl="3"/>
             <a:r>
-              <a:rPr lang="en-US" smtClean="0"/>
+              <a:rPr lang="en-US"/>
               <a:t>Fourth level</a:t>
             </a:r>
           </a:p>
           <a:p>
             <a:pPr lvl="4"/>
             <a:r>
-              <a:rPr lang="en-US" smtClean="0"/>
+              <a:rPr lang="en-US"/>
               <a:t>Fifth level</a:t>
             </a:r>
-            <a:endParaRPr lang="en-US"/>
           </a:p>
         </p:txBody>
       </p:sp>
@@ -2247,7 +2245,7 @@
           <a:p>
             <a:pPr lvl="0"/>
             <a:r>
-              <a:rPr lang="en-US" smtClean="0"/>
+              <a:rPr lang="en-US"/>
               <a:t>Click to edit Master text styles</a:t>
             </a:r>
           </a:p>
@@ -2270,7 +2268,7 @@
           <a:p>
             <a:fld id="{5BCAD085-E8A6-8845-BD4E-CB4CCA059FC4}" type="datetimeFigureOut">
               <a:rPr lang="en-US" smtClean="0"/>
-              <a:t>1/27/13</a:t>
+              <a:t>6/30/26</a:t>
             </a:fld>
             <a:endParaRPr lang="en-US"/>
           </a:p>
@@ -2373,10 +2371,9 @@
           </a:lstStyle>
           <a:p>
             <a:r>
-              <a:rPr lang="en-US" smtClean="0"/>
+              <a:rPr lang="en-US"/>
               <a:t>Click to edit Master title style</a:t>
             </a:r>
-            <a:endParaRPr lang="en-US"/>
           </a:p>
         </p:txBody>
       </p:sp>
@@ -2500,7 +2497,7 @@
           <a:p>
             <a:pPr lvl="0"/>
             <a:r>
-              <a:rPr lang="en-US" smtClean="0"/>
+              <a:rPr lang="en-US"/>
               <a:t>Click to edit Master text styles</a:t>
             </a:r>
           </a:p>
@@ -2523,7 +2520,7 @@
           <a:p>
             <a:fld id="{5BCAD085-E8A6-8845-BD4E-CB4CCA059FC4}" type="datetimeFigureOut">
               <a:rPr lang="en-US" smtClean="0"/>
-              <a:t>1/27/13</a:t>
+              <a:t>6/30/26</a:t>
             </a:fld>
             <a:endParaRPr lang="en-US"/>
           </a:p>
@@ -2632,10 +2629,9 @@
           <a:lstStyle/>
           <a:p>
             <a:r>
-              <a:rPr lang="en-US" smtClean="0"/>
+              <a:rPr lang="en-US"/>
               <a:t>Click to edit Master title style</a:t>
             </a:r>
-            <a:endParaRPr lang="en-US"/>
           </a:p>
         </p:txBody>
       </p:sp>
@@ -2666,38 +2662,37 @@
           <a:p>
             <a:pPr lvl="0"/>
             <a:r>
-              <a:rPr lang="en-US" smtClean="0"/>
+              <a:rPr lang="en-US"/>
               <a:t>Click to edit Master text styles</a:t>
             </a:r>
           </a:p>
           <a:p>
             <a:pPr lvl="1"/>
             <a:r>
-              <a:rPr lang="en-US" smtClean="0"/>
+              <a:rPr lang="en-US"/>
               <a:t>Second level</a:t>
             </a:r>
           </a:p>
           <a:p>
             <a:pPr lvl="2"/>
             <a:r>
-              <a:rPr lang="en-US" smtClean="0"/>
+              <a:rPr lang="en-US"/>
               <a:t>Third level</a:t>
             </a:r>
           </a:p>
           <a:p>
             <a:pPr lvl="3"/>
             <a:r>
-              <a:rPr lang="en-US" smtClean="0"/>
+              <a:rPr lang="en-US"/>
               <a:t>Fourth level</a:t>
             </a:r>
           </a:p>
           <a:p>
             <a:pPr lvl="4"/>
             <a:r>
-              <a:rPr lang="en-US" smtClean="0"/>
+              <a:rPr lang="en-US"/>
               <a:t>Fifth level</a:t>
             </a:r>
-            <a:endParaRPr lang="en-US"/>
           </a:p>
         </p:txBody>
       </p:sp>
@@ -2736,7 +2731,7 @@
           <a:p>
             <a:fld id="{5BCAD085-E8A6-8845-BD4E-CB4CCA059FC4}" type="datetimeFigureOut">
               <a:rPr lang="en-US" smtClean="0"/>
-              <a:t>1/27/13</a:t>
+              <a:t>6/30/26</a:t>
             </a:fld>
             <a:endParaRPr lang="en-US"/>
           </a:p>
@@ -3095,7 +3090,7 @@
 </file>
 
 <file path=ppt/slides/slide1.xml><?xml version="1.0" encoding="utf-8"?>
-<p:sld xmlns:a="http://schemas.openxmlformats.org/drawingml/2006/main" xmlns:p="http://schemas.openxmlformats.org/presentationml/2006/main" xmlns:r="http://schemas.openxmlformats.org/officeDocument/2006/relationships">
+<p:sld xmlns:a="http://schemas.openxmlformats.org/drawingml/2006/main" xmlns:r="http://schemas.openxmlformats.org/officeDocument/2006/relationships" xmlns:p="http://schemas.openxmlformats.org/presentationml/2006/main">
   <p:cSld>
     <p:bg>
       <p:bgPr>
@@ -3111,7 +3106,14 @@
         <p:cNvGrpSpPr/>
         <p:nvPr/>
       </p:nvGrpSpPr>
-      <p:grpSpPr/>
+      <p:grpSpPr>
+        <a:xfrm>
+          <a:off x="0" y="0"/>
+          <a:ext cx="0" cy="0"/>
+          <a:chOff x="0" y="0"/>
+          <a:chExt cx="0" cy="0"/>
+        </a:xfrm>
+      </p:grpSpPr>
       <p:sp>
         <p:nvSpPr>
           <p:cNvPr id="2" name="Rectangle 1"/>
@@ -3152,6 +3154,7 @@
           <a:lstStyle/>
           <a:p>
             <a:pPr algn="ctr"/>
+            <a:endParaRPr/>
           </a:p>
         </p:txBody>
       </p:sp>
@@ -3164,7 +3167,7 @@
         <p:spPr>
           <a:xfrm>
             <a:off x="365760" y="1280160"/>
-            <a:ext cx="11457432" cy="1234440"/>
+            <a:ext cx="11457432" cy="892552"/>
           </a:xfrm>
           <a:prstGeom prst="rect">
             <a:avLst/>
@@ -3179,7 +3182,7 @@
           <a:p>
             <a:pPr algn="ctr"/>
             <a:r>
-              <a:rPr sz="5200" b="1" i="0">
+              <a:rPr lang="en-US" sz="5200" b="1" i="0" dirty="0">
                 <a:solidFill>
                   <a:srgbClr val="FFFFFF"/>
                 </a:solidFill>
@@ -3187,8 +3190,49 @@
                 <a:ea typeface="微軟正黑體"/>
                 <a:cs typeface="微軟正黑體"/>
               </a:rPr>
-              <a:t>小五 STEAM 嘗鮮課</a:t>
-            </a:r>
+              <a:t>AI x</a:t>
+            </a:r>
+            <a:r>
+              <a:rPr sz="5200" b="1" i="0" dirty="0">
+                <a:solidFill>
+                  <a:srgbClr val="FFFFFF"/>
+                </a:solidFill>
+                <a:latin typeface="微軟正黑體"/>
+                <a:ea typeface="微軟正黑體"/>
+                <a:cs typeface="微軟正黑體"/>
+              </a:rPr>
+              <a:t> STEAM </a:t>
+            </a:r>
+            <a:r>
+              <a:rPr lang="en-US" sz="5200" b="1" dirty="0" err="1">
+                <a:solidFill>
+                  <a:srgbClr val="FFFFFF"/>
+                </a:solidFill>
+                <a:latin typeface="微軟正黑體"/>
+                <a:ea typeface="微軟正黑體"/>
+                <a:cs typeface="微軟正黑體"/>
+              </a:rPr>
+              <a:t>體驗</a:t>
+            </a:r>
+            <a:r>
+              <a:rPr sz="5200" b="1" i="0" dirty="0" err="1">
+                <a:solidFill>
+                  <a:srgbClr val="FFFFFF"/>
+                </a:solidFill>
+                <a:latin typeface="微軟正黑體"/>
+                <a:ea typeface="微軟正黑體"/>
+                <a:cs typeface="微軟正黑體"/>
+              </a:rPr>
+              <a:t>課</a:t>
+            </a:r>
+            <a:endParaRPr sz="5200" b="1" i="0" dirty="0">
+              <a:solidFill>
+                <a:srgbClr val="FFFFFF"/>
+              </a:solidFill>
+              <a:latin typeface="微軟正黑體"/>
+              <a:ea typeface="微軟正黑體"/>
+              <a:cs typeface="微軟正黑體"/>
+            </a:endParaRPr>
           </a:p>
         </p:txBody>
       </p:sp>
@@ -3201,7 +3245,7 @@
         <p:spPr>
           <a:xfrm>
             <a:off x="365760" y="2697480"/>
-            <a:ext cx="11457432" cy="777240"/>
+            <a:ext cx="11457432" cy="615553"/>
           </a:xfrm>
           <a:prstGeom prst="rect">
             <a:avLst/>
@@ -3216,7 +3260,7 @@
           <a:p>
             <a:pPr algn="ctr"/>
             <a:r>
-              <a:rPr sz="3400" b="1" i="0">
+              <a:rPr lang="en-HK" sz="3400" b="1" i="0" dirty="0" err="1">
                 <a:solidFill>
                   <a:srgbClr val="BFDBFF"/>
                 </a:solidFill>
@@ -3224,8 +3268,16 @@
                 <a:ea typeface="微軟正黑體"/>
                 <a:cs typeface="微軟正黑體"/>
               </a:rPr>
-              <a:t>動手做 AI 小裝置</a:t>
-            </a:r>
+              <a:t>迦密聖道中學</a:t>
+            </a:r>
+            <a:endParaRPr sz="3400" b="1" i="0" dirty="0">
+              <a:solidFill>
+                <a:srgbClr val="BFDBFF"/>
+              </a:solidFill>
+              <a:latin typeface="微軟正黑體"/>
+              <a:ea typeface="微軟正黑體"/>
+              <a:cs typeface="微軟正黑體"/>
+            </a:endParaRPr>
           </a:p>
         </p:txBody>
       </p:sp>
@@ -3312,7 +3364,7 @@
 </file>
 
 <file path=ppt/slides/slide10.xml><?xml version="1.0" encoding="utf-8"?>
-<p:sld xmlns:a="http://schemas.openxmlformats.org/drawingml/2006/main" xmlns:p="http://schemas.openxmlformats.org/presentationml/2006/main" xmlns:r="http://schemas.openxmlformats.org/officeDocument/2006/relationships">
+<p:sld xmlns:a="http://schemas.openxmlformats.org/drawingml/2006/main" xmlns:r="http://schemas.openxmlformats.org/officeDocument/2006/relationships" xmlns:p="http://schemas.openxmlformats.org/presentationml/2006/main">
   <p:cSld>
     <p:spTree>
       <p:nvGrpSpPr>
@@ -3320,7 +3372,14 @@
         <p:cNvGrpSpPr/>
         <p:nvPr/>
       </p:nvGrpSpPr>
-      <p:grpSpPr/>
+      <p:grpSpPr>
+        <a:xfrm>
+          <a:off x="0" y="0"/>
+          <a:ext cx="0" cy="0"/>
+          <a:chOff x="0" y="0"/>
+          <a:chExt cx="0" cy="0"/>
+        </a:xfrm>
+      </p:grpSpPr>
       <p:sp>
         <p:nvSpPr>
           <p:cNvPr id="2" name="Rectangle 1"/>
@@ -3361,6 +3420,7 @@
           <a:lstStyle/>
           <a:p>
             <a:pPr algn="ctr"/>
+            <a:endParaRPr/>
           </a:p>
         </p:txBody>
       </p:sp>
@@ -3470,8 +3530,8 @@
         </p:nvSpPr>
         <p:spPr>
           <a:xfrm>
-            <a:off x="3566160" y="1024128"/>
-            <a:ext cx="8412480" cy="438912"/>
+            <a:off x="6172200" y="4278719"/>
+            <a:ext cx="5231851" cy="384721"/>
           </a:xfrm>
           <a:prstGeom prst="rect">
             <a:avLst/>
@@ -3486,7 +3546,7 @@
           <a:p>
             <a:pPr algn="l"/>
             <a:r>
-              <a:rPr sz="1900" b="1" i="0">
+              <a:rPr sz="1900" b="1" i="0" dirty="0">
                 <a:solidFill>
                   <a:srgbClr val="057A55"/>
                 </a:solidFill>
@@ -3494,7 +3554,29 @@
                 <a:ea typeface="微軟正黑體"/>
                 <a:cs typeface="微軟正黑體"/>
               </a:rPr>
-              <a:t>④  按以下方式砌積木：</a:t>
+              <a:t>④  </a:t>
+            </a:r>
+            <a:r>
+              <a:rPr sz="1900" b="1" i="0" dirty="0" err="1">
+                <a:solidFill>
+                  <a:srgbClr val="057A55"/>
+                </a:solidFill>
+                <a:latin typeface="微軟正黑體"/>
+                <a:ea typeface="微軟正黑體"/>
+                <a:cs typeface="微軟正黑體"/>
+              </a:rPr>
+              <a:t>按以下方式砌積木</a:t>
+            </a:r>
+            <a:r>
+              <a:rPr sz="1900" b="1" i="0" dirty="0">
+                <a:solidFill>
+                  <a:srgbClr val="057A55"/>
+                </a:solidFill>
+                <a:latin typeface="微軟正黑體"/>
+                <a:ea typeface="微軟正黑體"/>
+                <a:cs typeface="微軟正黑體"/>
+              </a:rPr>
+              <a:t>：</a:t>
             </a:r>
           </a:p>
         </p:txBody>
@@ -3515,8 +3597,8 @@
         </p:blipFill>
         <p:spPr>
           <a:xfrm>
-            <a:off x="3566160" y="1463040"/>
-            <a:ext cx="5486400" cy="10202950"/>
+            <a:off x="9168714" y="1181161"/>
+            <a:ext cx="2033922" cy="3782445"/>
           </a:xfrm>
           <a:prstGeom prst="rect">
             <a:avLst/>
@@ -3563,6 +3645,7 @@
           <a:lstStyle/>
           <a:p>
             <a:pPr algn="ctr"/>
+            <a:endParaRPr/>
           </a:p>
         </p:txBody>
       </p:sp>
@@ -3686,7 +3769,7 @@
 </file>
 
 <file path=ppt/slides/slide11.xml><?xml version="1.0" encoding="utf-8"?>
-<p:sld xmlns:a="http://schemas.openxmlformats.org/drawingml/2006/main" xmlns:p="http://schemas.openxmlformats.org/presentationml/2006/main" xmlns:r="http://schemas.openxmlformats.org/officeDocument/2006/relationships">
+<p:sld xmlns:a="http://schemas.openxmlformats.org/drawingml/2006/main" xmlns:r="http://schemas.openxmlformats.org/officeDocument/2006/relationships" xmlns:p="http://schemas.openxmlformats.org/presentationml/2006/main">
   <p:cSld>
     <p:spTree>
       <p:nvGrpSpPr>
@@ -3694,7 +3777,14 @@
         <p:cNvGrpSpPr/>
         <p:nvPr/>
       </p:nvGrpSpPr>
-      <p:grpSpPr/>
+      <p:grpSpPr>
+        <a:xfrm>
+          <a:off x="0" y="0"/>
+          <a:ext cx="0" cy="0"/>
+          <a:chOff x="0" y="0"/>
+          <a:chExt cx="0" cy="0"/>
+        </a:xfrm>
+      </p:grpSpPr>
       <p:sp>
         <p:nvSpPr>
           <p:cNvPr id="2" name="Rectangle 1"/>
@@ -3735,6 +3825,7 @@
           <a:lstStyle/>
           <a:p>
             <a:pPr algn="ctr"/>
+            <a:endParaRPr/>
           </a:p>
         </p:txBody>
       </p:sp>
@@ -3815,6 +3906,7 @@
           <a:lstStyle/>
           <a:p>
             <a:pPr algn="ctr"/>
+            <a:endParaRPr/>
           </a:p>
         </p:txBody>
       </p:sp>
@@ -3932,6 +4024,7 @@
           <a:lstStyle/>
           <a:p>
             <a:pPr algn="ctr"/>
+            <a:endParaRPr/>
           </a:p>
         </p:txBody>
       </p:sp>
@@ -4116,7 +4209,7 @@
 </file>
 
 <file path=ppt/slides/slide12.xml><?xml version="1.0" encoding="utf-8"?>
-<p:sld xmlns:a="http://schemas.openxmlformats.org/drawingml/2006/main" xmlns:p="http://schemas.openxmlformats.org/presentationml/2006/main" xmlns:r="http://schemas.openxmlformats.org/officeDocument/2006/relationships">
+<p:sld xmlns:a="http://schemas.openxmlformats.org/drawingml/2006/main" xmlns:r="http://schemas.openxmlformats.org/officeDocument/2006/relationships" xmlns:p="http://schemas.openxmlformats.org/presentationml/2006/main">
   <p:cSld>
     <p:bg>
       <p:bgPr>
@@ -4132,7 +4225,14 @@
         <p:cNvGrpSpPr/>
         <p:nvPr/>
       </p:nvGrpSpPr>
-      <p:grpSpPr/>
+      <p:grpSpPr>
+        <a:xfrm>
+          <a:off x="0" y="0"/>
+          <a:ext cx="0" cy="0"/>
+          <a:chOff x="0" y="0"/>
+          <a:chExt cx="0" cy="0"/>
+        </a:xfrm>
+      </p:grpSpPr>
       <p:sp>
         <p:nvSpPr>
           <p:cNvPr id="2" name="Rectangle 1"/>
@@ -4173,6 +4273,7 @@
           <a:lstStyle/>
           <a:p>
             <a:pPr algn="ctr"/>
+            <a:endParaRPr/>
           </a:p>
         </p:txBody>
       </p:sp>
@@ -4296,7 +4397,7 @@
 </file>
 
 <file path=ppt/slides/slide13.xml><?xml version="1.0" encoding="utf-8"?>
-<p:sld xmlns:a="http://schemas.openxmlformats.org/drawingml/2006/main" xmlns:p="http://schemas.openxmlformats.org/presentationml/2006/main" xmlns:r="http://schemas.openxmlformats.org/officeDocument/2006/relationships">
+<p:sld xmlns:a="http://schemas.openxmlformats.org/drawingml/2006/main" xmlns:r="http://schemas.openxmlformats.org/officeDocument/2006/relationships" xmlns:p="http://schemas.openxmlformats.org/presentationml/2006/main">
   <p:cSld>
     <p:spTree>
       <p:nvGrpSpPr>
@@ -4304,7 +4405,14 @@
         <p:cNvGrpSpPr/>
         <p:nvPr/>
       </p:nvGrpSpPr>
-      <p:grpSpPr/>
+      <p:grpSpPr>
+        <a:xfrm>
+          <a:off x="0" y="0"/>
+          <a:ext cx="0" cy="0"/>
+          <a:chOff x="0" y="0"/>
+          <a:chExt cx="0" cy="0"/>
+        </a:xfrm>
+      </p:grpSpPr>
       <p:sp>
         <p:nvSpPr>
           <p:cNvPr id="2" name="Rectangle 1"/>
@@ -4345,6 +4453,7 @@
           <a:lstStyle/>
           <a:p>
             <a:pPr algn="ctr"/>
+            <a:endParaRPr/>
           </a:p>
         </p:txBody>
       </p:sp>
@@ -4699,7 +4808,7 @@
 </file>
 
 <file path=ppt/slides/slide14.xml><?xml version="1.0" encoding="utf-8"?>
-<p:sld xmlns:a="http://schemas.openxmlformats.org/drawingml/2006/main" xmlns:p="http://schemas.openxmlformats.org/presentationml/2006/main" xmlns:r="http://schemas.openxmlformats.org/officeDocument/2006/relationships">
+<p:sld xmlns:a="http://schemas.openxmlformats.org/drawingml/2006/main" xmlns:r="http://schemas.openxmlformats.org/officeDocument/2006/relationships" xmlns:p="http://schemas.openxmlformats.org/presentationml/2006/main">
   <p:cSld>
     <p:spTree>
       <p:nvGrpSpPr>
@@ -4707,7 +4816,14 @@
         <p:cNvGrpSpPr/>
         <p:nvPr/>
       </p:nvGrpSpPr>
-      <p:grpSpPr/>
+      <p:grpSpPr>
+        <a:xfrm>
+          <a:off x="0" y="0"/>
+          <a:ext cx="0" cy="0"/>
+          <a:chOff x="0" y="0"/>
+          <a:chExt cx="0" cy="0"/>
+        </a:xfrm>
+      </p:grpSpPr>
       <p:sp>
         <p:nvSpPr>
           <p:cNvPr id="2" name="Rectangle 1"/>
@@ -4748,6 +4864,7 @@
           <a:lstStyle/>
           <a:p>
             <a:pPr algn="ctr"/>
+            <a:endParaRPr/>
           </a:p>
         </p:txBody>
       </p:sp>
@@ -4865,6 +4982,7 @@
           <a:lstStyle/>
           <a:p>
             <a:pPr algn="ctr"/>
+            <a:endParaRPr/>
           </a:p>
         </p:txBody>
       </p:sp>
@@ -4945,6 +5063,7 @@
           <a:lstStyle/>
           <a:p>
             <a:pPr algn="ctr"/>
+            <a:endParaRPr/>
           </a:p>
         </p:txBody>
       </p:sp>
@@ -5025,6 +5144,7 @@
           <a:lstStyle/>
           <a:p>
             <a:pPr algn="ctr"/>
+            <a:endParaRPr/>
           </a:p>
         </p:txBody>
       </p:sp>
@@ -5105,6 +5225,7 @@
           <a:lstStyle/>
           <a:p>
             <a:pPr algn="ctr"/>
+            <a:endParaRPr/>
           </a:p>
         </p:txBody>
       </p:sp>
@@ -5148,6 +5269,7 @@
           <a:lstStyle/>
           <a:p>
             <a:pPr algn="ctr"/>
+            <a:endParaRPr/>
           </a:p>
         </p:txBody>
       </p:sp>
@@ -5191,6 +5313,7 @@
           <a:lstStyle/>
           <a:p>
             <a:pPr algn="ctr"/>
+            <a:endParaRPr/>
           </a:p>
         </p:txBody>
       </p:sp>
@@ -5271,6 +5394,7 @@
           <a:lstStyle/>
           <a:p>
             <a:pPr algn="ctr"/>
+            <a:endParaRPr/>
           </a:p>
         </p:txBody>
       </p:sp>
@@ -5314,6 +5438,7 @@
           <a:lstStyle/>
           <a:p>
             <a:pPr algn="ctr"/>
+            <a:endParaRPr/>
           </a:p>
         </p:txBody>
       </p:sp>
@@ -5357,6 +5482,7 @@
           <a:lstStyle/>
           <a:p>
             <a:pPr algn="ctr"/>
+            <a:endParaRPr/>
           </a:p>
         </p:txBody>
       </p:sp>
@@ -5437,6 +5563,7 @@
           <a:lstStyle/>
           <a:p>
             <a:pPr algn="ctr"/>
+            <a:endParaRPr/>
           </a:p>
         </p:txBody>
       </p:sp>
@@ -5480,6 +5607,7 @@
           <a:lstStyle/>
           <a:p>
             <a:pPr algn="ctr"/>
+            <a:endParaRPr/>
           </a:p>
         </p:txBody>
       </p:sp>
@@ -5523,6 +5651,7 @@
           <a:lstStyle/>
           <a:p>
             <a:pPr algn="ctr"/>
+            <a:endParaRPr/>
           </a:p>
         </p:txBody>
       </p:sp>
@@ -5603,6 +5732,7 @@
           <a:lstStyle/>
           <a:p>
             <a:pPr algn="ctr"/>
+            <a:endParaRPr/>
           </a:p>
         </p:txBody>
       </p:sp>
@@ -5646,6 +5776,7 @@
           <a:lstStyle/>
           <a:p>
             <a:pPr algn="ctr"/>
+            <a:endParaRPr/>
           </a:p>
         </p:txBody>
       </p:sp>
@@ -5689,6 +5820,7 @@
           <a:lstStyle/>
           <a:p>
             <a:pPr algn="ctr"/>
+            <a:endParaRPr/>
           </a:p>
         </p:txBody>
       </p:sp>
@@ -5769,6 +5901,7 @@
           <a:lstStyle/>
           <a:p>
             <a:pPr algn="ctr"/>
+            <a:endParaRPr/>
           </a:p>
         </p:txBody>
       </p:sp>
@@ -5812,6 +5945,7 @@
           <a:lstStyle/>
           <a:p>
             <a:pPr algn="ctr"/>
+            <a:endParaRPr/>
           </a:p>
         </p:txBody>
       </p:sp>
@@ -5855,6 +5989,7 @@
           <a:lstStyle/>
           <a:p>
             <a:pPr algn="ctr"/>
+            <a:endParaRPr/>
           </a:p>
         </p:txBody>
       </p:sp>
@@ -5935,6 +6070,7 @@
           <a:lstStyle/>
           <a:p>
             <a:pPr algn="ctr"/>
+            <a:endParaRPr/>
           </a:p>
         </p:txBody>
       </p:sp>
@@ -6015,6 +6151,7 @@
           <a:lstStyle/>
           <a:p>
             <a:pPr algn="ctr"/>
+            <a:endParaRPr/>
           </a:p>
         </p:txBody>
       </p:sp>
@@ -6096,6 +6233,7 @@
           <a:lstStyle/>
           <a:p>
             <a:pPr algn="ctr"/>
+            <a:endParaRPr/>
           </a:p>
         </p:txBody>
       </p:sp>
@@ -6177,6 +6315,7 @@
           <a:lstStyle/>
           <a:p>
             <a:pPr algn="ctr"/>
+            <a:endParaRPr/>
           </a:p>
         </p:txBody>
       </p:sp>
@@ -6258,6 +6397,7 @@
           <a:lstStyle/>
           <a:p>
             <a:pPr algn="ctr"/>
+            <a:endParaRPr/>
           </a:p>
         </p:txBody>
       </p:sp>
@@ -6339,6 +6479,7 @@
           <a:lstStyle/>
           <a:p>
             <a:pPr algn="ctr"/>
+            <a:endParaRPr/>
           </a:p>
         </p:txBody>
       </p:sp>
@@ -6389,7 +6530,7 @@
 </file>
 
 <file path=ppt/slides/slide15.xml><?xml version="1.0" encoding="utf-8"?>
-<p:sld xmlns:a="http://schemas.openxmlformats.org/drawingml/2006/main" xmlns:p="http://schemas.openxmlformats.org/presentationml/2006/main" xmlns:r="http://schemas.openxmlformats.org/officeDocument/2006/relationships">
+<p:sld xmlns:a="http://schemas.openxmlformats.org/drawingml/2006/main" xmlns:r="http://schemas.openxmlformats.org/officeDocument/2006/relationships" xmlns:p="http://schemas.openxmlformats.org/presentationml/2006/main">
   <p:cSld>
     <p:spTree>
       <p:nvGrpSpPr>
@@ -6397,7 +6538,14 @@
         <p:cNvGrpSpPr/>
         <p:nvPr/>
       </p:nvGrpSpPr>
-      <p:grpSpPr/>
+      <p:grpSpPr>
+        <a:xfrm>
+          <a:off x="0" y="0"/>
+          <a:ext cx="0" cy="0"/>
+          <a:chOff x="0" y="0"/>
+          <a:chExt cx="0" cy="0"/>
+        </a:xfrm>
+      </p:grpSpPr>
       <p:sp>
         <p:nvSpPr>
           <p:cNvPr id="2" name="Rectangle 1"/>
@@ -6438,6 +6586,7 @@
           <a:lstStyle/>
           <a:p>
             <a:pPr algn="ctr"/>
+            <a:endParaRPr/>
           </a:p>
         </p:txBody>
       </p:sp>
@@ -6555,6 +6704,7 @@
           <a:lstStyle/>
           <a:p>
             <a:pPr algn="ctr"/>
+            <a:endParaRPr/>
           </a:p>
         </p:txBody>
       </p:sp>
@@ -6787,7 +6937,7 @@
 </file>
 
 <file path=ppt/slides/slide16.xml><?xml version="1.0" encoding="utf-8"?>
-<p:sld xmlns:a="http://schemas.openxmlformats.org/drawingml/2006/main" xmlns:p="http://schemas.openxmlformats.org/presentationml/2006/main" xmlns:r="http://schemas.openxmlformats.org/officeDocument/2006/relationships">
+<p:sld xmlns:a="http://schemas.openxmlformats.org/drawingml/2006/main" xmlns:r="http://schemas.openxmlformats.org/officeDocument/2006/relationships" xmlns:p="http://schemas.openxmlformats.org/presentationml/2006/main">
   <p:cSld>
     <p:spTree>
       <p:nvGrpSpPr>
@@ -6795,7 +6945,14 @@
         <p:cNvGrpSpPr/>
         <p:nvPr/>
       </p:nvGrpSpPr>
-      <p:grpSpPr/>
+      <p:grpSpPr>
+        <a:xfrm>
+          <a:off x="0" y="0"/>
+          <a:ext cx="0" cy="0"/>
+          <a:chOff x="0" y="0"/>
+          <a:chExt cx="0" cy="0"/>
+        </a:xfrm>
+      </p:grpSpPr>
       <p:sp>
         <p:nvSpPr>
           <p:cNvPr id="2" name="Rectangle 1"/>
@@ -6836,6 +6993,7 @@
           <a:lstStyle/>
           <a:p>
             <a:pPr algn="ctr"/>
+            <a:endParaRPr/>
           </a:p>
         </p:txBody>
       </p:sp>
@@ -7207,7 +7365,7 @@
 </file>
 
 <file path=ppt/slides/slide17.xml><?xml version="1.0" encoding="utf-8"?>
-<p:sld xmlns:a="http://schemas.openxmlformats.org/drawingml/2006/main" xmlns:p="http://schemas.openxmlformats.org/presentationml/2006/main" xmlns:r="http://schemas.openxmlformats.org/officeDocument/2006/relationships">
+<p:sld xmlns:a="http://schemas.openxmlformats.org/drawingml/2006/main" xmlns:r="http://schemas.openxmlformats.org/officeDocument/2006/relationships" xmlns:p="http://schemas.openxmlformats.org/presentationml/2006/main">
   <p:cSld>
     <p:spTree>
       <p:nvGrpSpPr>
@@ -7215,7 +7373,14 @@
         <p:cNvGrpSpPr/>
         <p:nvPr/>
       </p:nvGrpSpPr>
-      <p:grpSpPr/>
+      <p:grpSpPr>
+        <a:xfrm>
+          <a:off x="0" y="0"/>
+          <a:ext cx="0" cy="0"/>
+          <a:chOff x="0" y="0"/>
+          <a:chExt cx="0" cy="0"/>
+        </a:xfrm>
+      </p:grpSpPr>
       <p:sp>
         <p:nvSpPr>
           <p:cNvPr id="2" name="Rectangle 1"/>
@@ -7256,6 +7421,7 @@
           <a:lstStyle/>
           <a:p>
             <a:pPr algn="ctr"/>
+            <a:endParaRPr/>
           </a:p>
         </p:txBody>
       </p:sp>
@@ -7373,6 +7539,7 @@
           <a:lstStyle/>
           <a:p>
             <a:pPr algn="ctr"/>
+            <a:endParaRPr/>
           </a:p>
         </p:txBody>
       </p:sp>
@@ -7688,6 +7855,7 @@
           <a:lstStyle/>
           <a:p>
             <a:pPr algn="ctr"/>
+            <a:endParaRPr/>
           </a:p>
         </p:txBody>
       </p:sp>
@@ -7737,7 +7905,7 @@
 </file>
 
 <file path=ppt/slides/slide2.xml><?xml version="1.0" encoding="utf-8"?>
-<p:sld xmlns:a="http://schemas.openxmlformats.org/drawingml/2006/main" xmlns:p="http://schemas.openxmlformats.org/presentationml/2006/main" xmlns:r="http://schemas.openxmlformats.org/officeDocument/2006/relationships">
+<p:sld xmlns:a="http://schemas.openxmlformats.org/drawingml/2006/main" xmlns:r="http://schemas.openxmlformats.org/officeDocument/2006/relationships" xmlns:p="http://schemas.openxmlformats.org/presentationml/2006/main">
   <p:cSld>
     <p:spTree>
       <p:nvGrpSpPr>
@@ -7745,7 +7913,14 @@
         <p:cNvGrpSpPr/>
         <p:nvPr/>
       </p:nvGrpSpPr>
-      <p:grpSpPr/>
+      <p:grpSpPr>
+        <a:xfrm>
+          <a:off x="0" y="0"/>
+          <a:ext cx="0" cy="0"/>
+          <a:chOff x="0" y="0"/>
+          <a:chExt cx="0" cy="0"/>
+        </a:xfrm>
+      </p:grpSpPr>
       <p:sp>
         <p:nvSpPr>
           <p:cNvPr id="2" name="Rectangle 1"/>
@@ -7786,6 +7961,7 @@
           <a:lstStyle/>
           <a:p>
             <a:pPr algn="ctr"/>
+            <a:endParaRPr/>
           </a:p>
         </p:txBody>
       </p:sp>
@@ -7866,6 +8042,7 @@
           <a:lstStyle/>
           <a:p>
             <a:pPr algn="ctr"/>
+            <a:endParaRPr/>
           </a:p>
         </p:txBody>
       </p:sp>
@@ -8021,6 +8198,7 @@
           <a:lstStyle/>
           <a:p>
             <a:pPr algn="ctr"/>
+            <a:endParaRPr/>
           </a:p>
         </p:txBody>
       </p:sp>
@@ -8176,6 +8354,7 @@
           <a:lstStyle/>
           <a:p>
             <a:pPr algn="ctr"/>
+            <a:endParaRPr/>
           </a:p>
         </p:txBody>
       </p:sp>
@@ -8331,6 +8510,7 @@
           <a:lstStyle/>
           <a:p>
             <a:pPr algn="ctr"/>
+            <a:endParaRPr/>
           </a:p>
         </p:txBody>
       </p:sp>
@@ -8380,7 +8560,7 @@
 </file>
 
 <file path=ppt/slides/slide3.xml><?xml version="1.0" encoding="utf-8"?>
-<p:sld xmlns:a="http://schemas.openxmlformats.org/drawingml/2006/main" xmlns:p="http://schemas.openxmlformats.org/presentationml/2006/main" xmlns:r="http://schemas.openxmlformats.org/officeDocument/2006/relationships">
+<p:sld xmlns:a="http://schemas.openxmlformats.org/drawingml/2006/main" xmlns:r="http://schemas.openxmlformats.org/officeDocument/2006/relationships" xmlns:p="http://schemas.openxmlformats.org/presentationml/2006/main">
   <p:cSld>
     <p:spTree>
       <p:nvGrpSpPr>
@@ -8388,7 +8568,14 @@
         <p:cNvGrpSpPr/>
         <p:nvPr/>
       </p:nvGrpSpPr>
-      <p:grpSpPr/>
+      <p:grpSpPr>
+        <a:xfrm>
+          <a:off x="0" y="0"/>
+          <a:ext cx="0" cy="0"/>
+          <a:chOff x="0" y="0"/>
+          <a:chExt cx="0" cy="0"/>
+        </a:xfrm>
+      </p:grpSpPr>
       <p:sp>
         <p:nvSpPr>
           <p:cNvPr id="2" name="Rectangle 1"/>
@@ -8429,6 +8616,7 @@
           <a:lstStyle/>
           <a:p>
             <a:pPr algn="ctr"/>
+            <a:endParaRPr/>
           </a:p>
         </p:txBody>
       </p:sp>
@@ -8683,6 +8871,7 @@
           <a:lstStyle/>
           <a:p>
             <a:pPr algn="ctr"/>
+            <a:endParaRPr/>
           </a:p>
         </p:txBody>
       </p:sp>
@@ -8695,7 +8884,7 @@
         <p:spPr>
           <a:xfrm>
             <a:off x="4114800" y="5303520"/>
-            <a:ext cx="7589520" cy="914400"/>
+            <a:ext cx="7589520" cy="646331"/>
           </a:xfrm>
           <a:prstGeom prst="rect">
             <a:avLst/>
@@ -8710,7 +8899,7 @@
           <a:p>
             <a:pPr algn="l"/>
             <a:r>
-              <a:rPr sz="1800" b="0" i="0">
+              <a:rPr sz="1800" b="0" i="0" dirty="0">
                 <a:solidFill>
                   <a:srgbClr val="1C64F2"/>
                 </a:solidFill>
@@ -8718,9 +8907,160 @@
                 <a:ea typeface="微軟正黑體"/>
                 <a:cs typeface="微軟正黑體"/>
               </a:rPr>
-              <a:t>🔵 BtnA（橙色側鍵）—— 主要操作按鈕
-🔵 BtnB（正面藍色按鈕）—— 次要按鈕 / 重設</a:t>
-            </a:r>
+              <a:t>🔵 </a:t>
+            </a:r>
+            <a:r>
+              <a:rPr sz="1800" b="0" i="0" dirty="0" err="1">
+                <a:solidFill>
+                  <a:srgbClr val="1C64F2"/>
+                </a:solidFill>
+                <a:latin typeface="微軟正黑體"/>
+                <a:ea typeface="微軟正黑體"/>
+                <a:cs typeface="微軟正黑體"/>
+              </a:rPr>
+              <a:t>BtnA</a:t>
+            </a:r>
+            <a:r>
+              <a:rPr sz="1800" b="0" i="0" dirty="0">
+                <a:solidFill>
+                  <a:srgbClr val="1C64F2"/>
+                </a:solidFill>
+                <a:latin typeface="微軟正黑體"/>
+                <a:ea typeface="微軟正黑體"/>
+                <a:cs typeface="微軟正黑體"/>
+              </a:rPr>
+              <a:t>（</a:t>
+            </a:r>
+            <a:r>
+              <a:rPr lang="zh-TW" altLang="en-US" sz="1800" b="0" i="0" dirty="0">
+                <a:solidFill>
+                  <a:srgbClr val="1C64F2"/>
+                </a:solidFill>
+                <a:latin typeface="微軟正黑體"/>
+                <a:ea typeface="微軟正黑體"/>
+                <a:cs typeface="微軟正黑體"/>
+              </a:rPr>
+              <a:t> 正面藍色按鈕</a:t>
+            </a:r>
+            <a:r>
+              <a:rPr sz="1800" b="0" i="0" dirty="0">
+                <a:solidFill>
+                  <a:srgbClr val="1C64F2"/>
+                </a:solidFill>
+                <a:latin typeface="微軟正黑體"/>
+                <a:ea typeface="微軟正黑體"/>
+                <a:cs typeface="微軟正黑體"/>
+              </a:rPr>
+              <a:t>）—— </a:t>
+            </a:r>
+            <a:r>
+              <a:rPr sz="1800" b="0" i="0" dirty="0" err="1">
+                <a:solidFill>
+                  <a:srgbClr val="1C64F2"/>
+                </a:solidFill>
+                <a:latin typeface="微軟正黑體"/>
+                <a:ea typeface="微軟正黑體"/>
+                <a:cs typeface="微軟正黑體"/>
+              </a:rPr>
+              <a:t>主要操作按鈕</a:t>
+            </a:r>
+            <a:r>
+              <a:rPr sz="1800" b="0" i="0" dirty="0">
+                <a:solidFill>
+                  <a:srgbClr val="1C64F2"/>
+                </a:solidFill>
+                <a:latin typeface="微軟正黑體"/>
+                <a:ea typeface="微軟正黑體"/>
+                <a:cs typeface="微軟正黑體"/>
+              </a:rPr>
+              <a:t>
+🔵 </a:t>
+            </a:r>
+            <a:r>
+              <a:rPr sz="1800" b="0" i="0" dirty="0" err="1">
+                <a:solidFill>
+                  <a:srgbClr val="1C64F2"/>
+                </a:solidFill>
+                <a:latin typeface="微軟正黑體"/>
+                <a:ea typeface="微軟正黑體"/>
+                <a:cs typeface="微軟正黑體"/>
+              </a:rPr>
+              <a:t>BtnB</a:t>
+            </a:r>
+            <a:r>
+              <a:rPr sz="1800" b="0" i="0" dirty="0">
+                <a:solidFill>
+                  <a:srgbClr val="1C64F2"/>
+                </a:solidFill>
+                <a:latin typeface="微軟正黑體"/>
+                <a:ea typeface="微軟正黑體"/>
+                <a:cs typeface="微軟正黑體"/>
+              </a:rPr>
+              <a:t>（</a:t>
+            </a:r>
+            <a:r>
+              <a:rPr lang="zh-TW" altLang="en-US" sz="1800" b="0" i="0" dirty="0">
+                <a:solidFill>
+                  <a:srgbClr val="1C64F2"/>
+                </a:solidFill>
+                <a:latin typeface="微軟正黑體"/>
+                <a:ea typeface="微軟正黑體"/>
+                <a:cs typeface="微軟正黑體"/>
+              </a:rPr>
+              <a:t> 右側鍵 </a:t>
+            </a:r>
+            <a:r>
+              <a:rPr sz="1800" b="0" i="0" dirty="0">
+                <a:solidFill>
+                  <a:srgbClr val="1C64F2"/>
+                </a:solidFill>
+                <a:latin typeface="微軟正黑體"/>
+                <a:ea typeface="微軟正黑體"/>
+                <a:cs typeface="微軟正黑體"/>
+              </a:rPr>
+              <a:t>）—— </a:t>
+            </a:r>
+            <a:r>
+              <a:rPr sz="1800" b="0" i="0" dirty="0" err="1">
+                <a:solidFill>
+                  <a:srgbClr val="1C64F2"/>
+                </a:solidFill>
+                <a:latin typeface="微軟正黑體"/>
+                <a:ea typeface="微軟正黑體"/>
+                <a:cs typeface="微軟正黑體"/>
+              </a:rPr>
+              <a:t>次要按鈕</a:t>
+            </a:r>
+            <a:r>
+              <a:rPr sz="1800" b="0" i="0" dirty="0">
+                <a:solidFill>
+                  <a:srgbClr val="1C64F2"/>
+                </a:solidFill>
+                <a:latin typeface="微軟正黑體"/>
+                <a:ea typeface="微軟正黑體"/>
+                <a:cs typeface="微軟正黑體"/>
+              </a:rPr>
+              <a:t> / </a:t>
+            </a:r>
+            <a:r>
+              <a:rPr sz="1800" b="0" i="0" dirty="0" err="1">
+                <a:solidFill>
+                  <a:srgbClr val="1C64F2"/>
+                </a:solidFill>
+                <a:latin typeface="微軟正黑體"/>
+                <a:ea typeface="微軟正黑體"/>
+                <a:cs typeface="微軟正黑體"/>
+              </a:rPr>
+              <a:t>重設</a:t>
+            </a:r>
+            <a:endParaRPr sz="1800" b="0" i="0" dirty="0">
+              <a:solidFill>
+                <a:srgbClr val="1C64F2"/>
+              </a:solidFill>
+              <a:latin typeface="微軟正黑體"/>
+              <a:ea typeface="微軟正黑體"/>
+              <a:cs typeface="微軟正黑體"/>
+            </a:endParaRPr>
           </a:p>
         </p:txBody>
       </p:sp>
@@ -8733,7 +9073,7 @@
 </file>
 
 <file path=ppt/slides/slide4.xml><?xml version="1.0" encoding="utf-8"?>
-<p:sld xmlns:a="http://schemas.openxmlformats.org/drawingml/2006/main" xmlns:p="http://schemas.openxmlformats.org/presentationml/2006/main" xmlns:r="http://schemas.openxmlformats.org/officeDocument/2006/relationships">
+<p:sld xmlns:a="http://schemas.openxmlformats.org/drawingml/2006/main" xmlns:r="http://schemas.openxmlformats.org/officeDocument/2006/relationships" xmlns:p="http://schemas.openxmlformats.org/presentationml/2006/main">
   <p:cSld>
     <p:bg>
       <p:bgPr>
@@ -8749,7 +9089,14 @@
         <p:cNvGrpSpPr/>
         <p:nvPr/>
       </p:nvGrpSpPr>
-      <p:grpSpPr/>
+      <p:grpSpPr>
+        <a:xfrm>
+          <a:off x="0" y="0"/>
+          <a:ext cx="0" cy="0"/>
+          <a:chOff x="0" y="0"/>
+          <a:chExt cx="0" cy="0"/>
+        </a:xfrm>
+      </p:grpSpPr>
       <p:sp>
         <p:nvSpPr>
           <p:cNvPr id="2" name="Rectangle 1"/>
@@ -8790,6 +9137,7 @@
           <a:lstStyle/>
           <a:p>
             <a:pPr algn="ctr"/>
+            <a:endParaRPr/>
           </a:p>
         </p:txBody>
       </p:sp>
@@ -8913,7 +9261,7 @@
 </file>
 
 <file path=ppt/slides/slide5.xml><?xml version="1.0" encoding="utf-8"?>
-<p:sld xmlns:a="http://schemas.openxmlformats.org/drawingml/2006/main" xmlns:p="http://schemas.openxmlformats.org/presentationml/2006/main" xmlns:r="http://schemas.openxmlformats.org/officeDocument/2006/relationships">
+<p:sld xmlns:a="http://schemas.openxmlformats.org/drawingml/2006/main" xmlns:r="http://schemas.openxmlformats.org/officeDocument/2006/relationships" xmlns:p="http://schemas.openxmlformats.org/presentationml/2006/main">
   <p:cSld>
     <p:spTree>
       <p:nvGrpSpPr>
@@ -8921,7 +9269,14 @@
         <p:cNvGrpSpPr/>
         <p:nvPr/>
       </p:nvGrpSpPr>
-      <p:grpSpPr/>
+      <p:grpSpPr>
+        <a:xfrm>
+          <a:off x="0" y="0"/>
+          <a:ext cx="0" cy="0"/>
+          <a:chOff x="0" y="0"/>
+          <a:chExt cx="0" cy="0"/>
+        </a:xfrm>
+      </p:grpSpPr>
       <p:sp>
         <p:nvSpPr>
           <p:cNvPr id="2" name="Rectangle 1"/>
@@ -8962,6 +9317,7 @@
           <a:lstStyle/>
           <a:p>
             <a:pPr algn="ctr"/>
+            <a:endParaRPr/>
           </a:p>
         </p:txBody>
       </p:sp>
@@ -9071,16 +9427,15 @@
           </p:cNvPicPr>
           <p:nvPr/>
         </p:nvPicPr>
-        <p:blipFill>
+        <p:blipFill rotWithShape="1">
           <a:blip r:embed="rId3"/>
-          <a:stretch>
-            <a:fillRect/>
-          </a:stretch>
+          <a:srcRect l="17838" t="1004" r="25000" b="90696"/>
+          <a:stretch/>
         </p:blipFill>
         <p:spPr>
           <a:xfrm>
-            <a:off x="4480560" y="1463040"/>
-            <a:ext cx="1828800" cy="2888974"/>
+            <a:off x="4806778" y="1492049"/>
+            <a:ext cx="1913640" cy="438911"/>
           </a:xfrm>
           <a:prstGeom prst="rect">
             <a:avLst/>
@@ -9265,16 +9620,15 @@
           </p:cNvPicPr>
           <p:nvPr/>
         </p:nvPicPr>
-        <p:blipFill>
+        <p:blipFill rotWithShape="1">
           <a:blip r:embed="rId8"/>
-          <a:stretch>
-            <a:fillRect/>
-          </a:stretch>
+          <a:srcRect l="20649" t="37744" r="39892" b="18408"/>
+          <a:stretch/>
         </p:blipFill>
         <p:spPr>
           <a:xfrm>
-            <a:off x="6583680" y="1417320"/>
-            <a:ext cx="2286000" cy="3283624"/>
+            <a:off x="7138076" y="1481328"/>
+            <a:ext cx="1313523" cy="2096600"/>
           </a:xfrm>
           <a:prstGeom prst="rect">
             <a:avLst/>
@@ -9290,7 +9644,7 @@
 </file>
 
 <file path=ppt/slides/slide6.xml><?xml version="1.0" encoding="utf-8"?>
-<p:sld xmlns:a="http://schemas.openxmlformats.org/drawingml/2006/main" xmlns:p="http://schemas.openxmlformats.org/presentationml/2006/main" xmlns:r="http://schemas.openxmlformats.org/officeDocument/2006/relationships">
+<p:sld xmlns:a="http://schemas.openxmlformats.org/drawingml/2006/main" xmlns:r="http://schemas.openxmlformats.org/officeDocument/2006/relationships" xmlns:p="http://schemas.openxmlformats.org/presentationml/2006/main">
   <p:cSld>
     <p:spTree>
       <p:nvGrpSpPr>
@@ -9298,7 +9652,14 @@
         <p:cNvGrpSpPr/>
         <p:nvPr/>
       </p:nvGrpSpPr>
-      <p:grpSpPr/>
+      <p:grpSpPr>
+        <a:xfrm>
+          <a:off x="0" y="0"/>
+          <a:ext cx="0" cy="0"/>
+          <a:chOff x="0" y="0"/>
+          <a:chExt cx="0" cy="0"/>
+        </a:xfrm>
+      </p:grpSpPr>
       <p:sp>
         <p:nvSpPr>
           <p:cNvPr id="2" name="Rectangle 1"/>
@@ -9339,6 +9700,7 @@
           <a:lstStyle/>
           <a:p>
             <a:pPr algn="ctr"/>
+            <a:endParaRPr/>
           </a:p>
         </p:txBody>
       </p:sp>
@@ -9442,14 +9804,14 @@
       </p:pic>
       <p:sp>
         <p:nvSpPr>
-          <p:cNvPr id="6" name="TextBox 5"/>
+          <p:cNvPr id="7" name="TextBox 6"/>
           <p:cNvSpPr txBox="1"/>
           <p:nvPr/>
         </p:nvSpPr>
         <p:spPr>
           <a:xfrm>
-            <a:off x="365760" y="1024128"/>
-            <a:ext cx="11457432" cy="438912"/>
+            <a:off x="5957316" y="1042416"/>
+            <a:ext cx="5669280" cy="438912"/>
           </a:xfrm>
           <a:prstGeom prst="rect">
             <a:avLst/>
@@ -9464,7 +9826,7 @@
           <a:p>
             <a:pPr algn="l"/>
             <a:r>
-              <a:rPr sz="1900" b="1" i="0">
+              <a:rPr sz="1900" b="1" i="0" dirty="0">
                 <a:solidFill>
                   <a:srgbClr val="1C64F2"/>
                 </a:solidFill>
@@ -9472,36 +9834,10 @@
                 <a:ea typeface="微軟正黑體"/>
                 <a:cs typeface="微軟正黑體"/>
               </a:rPr>
-              <a:t>④  拖入 2 個 Circle（眼睛）+ 1 條 Line（嘴巴）</a:t>
-            </a:r>
-          </a:p>
-        </p:txBody>
-      </p:sp>
-      <p:sp>
-        <p:nvSpPr>
-          <p:cNvPr id="7" name="TextBox 6"/>
-          <p:cNvSpPr txBox="1"/>
-          <p:nvPr/>
-        </p:nvSpPr>
-        <p:spPr>
-          <a:xfrm>
-            <a:off x="365760" y="4315968"/>
-            <a:ext cx="5669280" cy="438912"/>
-          </a:xfrm>
-          <a:prstGeom prst="rect">
-            <a:avLst/>
-          </a:prstGeom>
-          <a:noFill/>
-        </p:spPr>
-        <p:txBody>
-          <a:bodyPr wrap="square">
-            <a:spAutoFit/>
-          </a:bodyPr>
-          <a:lstStyle/>
-          <a:p>
-            <a:pPr algn="l"/>
-            <a:r>
-              <a:rPr sz="1900" b="1" i="0">
+              <a:t>④  </a:t>
+            </a:r>
+            <a:r>
+              <a:rPr sz="1900" b="1" i="0" dirty="0" err="1">
                 <a:solidFill>
                   <a:srgbClr val="1C64F2"/>
                 </a:solidFill>
@@ -9509,7 +9845,62 @@
                 <a:ea typeface="微軟正黑體"/>
                 <a:cs typeface="微軟正黑體"/>
               </a:rPr>
-              <a:t>④  拖入 2 個 Circle + 1 條 Line</a:t>
+              <a:t>拖入</a:t>
+            </a:r>
+            <a:r>
+              <a:rPr sz="1900" b="1" i="0" dirty="0">
+                <a:solidFill>
+                  <a:srgbClr val="1C64F2"/>
+                </a:solidFill>
+                <a:latin typeface="微軟正黑體"/>
+                <a:ea typeface="微軟正黑體"/>
+                <a:cs typeface="微軟正黑體"/>
+              </a:rPr>
+              <a:t> 2 </a:t>
+            </a:r>
+            <a:r>
+              <a:rPr sz="1900" b="1" i="0" dirty="0" err="1">
+                <a:solidFill>
+                  <a:srgbClr val="1C64F2"/>
+                </a:solidFill>
+                <a:latin typeface="微軟正黑體"/>
+                <a:ea typeface="微軟正黑體"/>
+                <a:cs typeface="微軟正黑體"/>
+              </a:rPr>
+              <a:t>個</a:t>
+            </a:r>
+            <a:r>
+              <a:rPr sz="1900" b="1" i="0" dirty="0">
+                <a:solidFill>
+                  <a:srgbClr val="1C64F2"/>
+                </a:solidFill>
+                <a:latin typeface="微軟正黑體"/>
+                <a:ea typeface="微軟正黑體"/>
+                <a:cs typeface="微軟正黑體"/>
+              </a:rPr>
+              <a:t> Circle + 1 </a:t>
+            </a:r>
+            <a:r>
+              <a:rPr sz="1900" b="1" i="0" dirty="0" err="1">
+                <a:solidFill>
+                  <a:srgbClr val="1C64F2"/>
+                </a:solidFill>
+                <a:latin typeface="微軟正黑體"/>
+                <a:ea typeface="微軟正黑體"/>
+                <a:cs typeface="微軟正黑體"/>
+              </a:rPr>
+              <a:t>條</a:t>
+            </a:r>
+            <a:r>
+              <a:rPr sz="1900" b="1" i="0" dirty="0">
+                <a:solidFill>
+                  <a:srgbClr val="1C64F2"/>
+                </a:solidFill>
+                <a:latin typeface="微軟正黑體"/>
+                <a:ea typeface="微軟正黑體"/>
+                <a:cs typeface="微軟正黑體"/>
+              </a:rPr>
+              <a:t> Line</a:t>
             </a:r>
           </a:p>
         </p:txBody>
@@ -9530,7 +9921,7 @@
         </p:blipFill>
         <p:spPr>
           <a:xfrm>
-            <a:off x="365760" y="4773168"/>
+            <a:off x="6080760" y="1518664"/>
             <a:ext cx="5394960" cy="4296920"/>
           </a:xfrm>
           <a:prstGeom prst="rect">
@@ -9540,14 +9931,14 @@
       </p:pic>
       <p:sp>
         <p:nvSpPr>
-          <p:cNvPr id="9" name="TextBox 8"/>
+          <p:cNvPr id="10" name="TextBox 9"/>
           <p:cNvSpPr txBox="1"/>
           <p:nvPr/>
         </p:nvSpPr>
         <p:spPr>
           <a:xfrm>
-            <a:off x="365760" y="1024128"/>
-            <a:ext cx="11457432" cy="438912"/>
+            <a:off x="379476" y="4553712"/>
+            <a:ext cx="5577840" cy="438912"/>
           </a:xfrm>
           <a:prstGeom prst="rect">
             <a:avLst/>
@@ -9562,7 +9953,7 @@
           <a:p>
             <a:pPr algn="l"/>
             <a:r>
-              <a:rPr sz="1900" b="1" i="0">
+              <a:rPr sz="1900" b="1" i="0" dirty="0">
                 <a:solidFill>
                   <a:srgbClr val="1C64F2"/>
                 </a:solidFill>
@@ -9570,36 +9961,10 @@
                 <a:ea typeface="微軟正黑體"/>
                 <a:cs typeface="微軟正黑體"/>
               </a:rPr>
-              <a:t>⑤  關閉編輯器 → 按「▶ Run Once」！</a:t>
-            </a:r>
-          </a:p>
-        </p:txBody>
-      </p:sp>
-      <p:sp>
-        <p:nvSpPr>
-          <p:cNvPr id="10" name="TextBox 9"/>
-          <p:cNvSpPr txBox="1"/>
-          <p:nvPr/>
-        </p:nvSpPr>
-        <p:spPr>
-          <a:xfrm>
-            <a:off x="6400800" y="4315968"/>
-            <a:ext cx="5577840" cy="438912"/>
-          </a:xfrm>
-          <a:prstGeom prst="rect">
-            <a:avLst/>
-          </a:prstGeom>
-          <a:noFill/>
-        </p:spPr>
-        <p:txBody>
-          <a:bodyPr wrap="square">
-            <a:spAutoFit/>
-          </a:bodyPr>
-          <a:lstStyle/>
-          <a:p>
-            <a:pPr algn="l"/>
-            <a:r>
-              <a:rPr sz="1900" b="1" i="0">
+              <a:t>⑤  </a:t>
+            </a:r>
+            <a:r>
+              <a:rPr sz="1900" b="1" i="0" dirty="0" err="1">
                 <a:solidFill>
                   <a:srgbClr val="1C64F2"/>
                 </a:solidFill>
@@ -9607,7 +9972,18 @@
                 <a:ea typeface="微軟正黑體"/>
                 <a:cs typeface="微軟正黑體"/>
               </a:rPr>
-              <a:t>⑤  關閉 → ▶ Run Once</a:t>
+              <a:t>關閉</a:t>
+            </a:r>
+            <a:r>
+              <a:rPr sz="1900" b="1" i="0" dirty="0">
+                <a:solidFill>
+                  <a:srgbClr val="1C64F2"/>
+                </a:solidFill>
+                <a:latin typeface="微軟正黑體"/>
+                <a:ea typeface="微軟正黑體"/>
+                <a:cs typeface="微軟正黑體"/>
+              </a:rPr>
+              <a:t> → ▶ Run Once</a:t>
             </a:r>
           </a:p>
         </p:txBody>
@@ -9628,7 +10004,7 @@
         </p:blipFill>
         <p:spPr>
           <a:xfrm>
-            <a:off x="6583680" y="4773168"/>
+            <a:off x="379476" y="5140189"/>
             <a:ext cx="2194560" cy="693683"/>
           </a:xfrm>
           <a:prstGeom prst="rect">
@@ -9645,7 +10021,7 @@
 </file>
 
 <file path=ppt/slides/slide7.xml><?xml version="1.0" encoding="utf-8"?>
-<p:sld xmlns:a="http://schemas.openxmlformats.org/drawingml/2006/main" xmlns:p="http://schemas.openxmlformats.org/presentationml/2006/main" xmlns:r="http://schemas.openxmlformats.org/officeDocument/2006/relationships">
+<p:sld xmlns:a="http://schemas.openxmlformats.org/drawingml/2006/main" xmlns:r="http://schemas.openxmlformats.org/officeDocument/2006/relationships" xmlns:p="http://schemas.openxmlformats.org/presentationml/2006/main">
   <p:cSld>
     <p:spTree>
       <p:nvGrpSpPr>
@@ -9653,7 +10029,14 @@
         <p:cNvGrpSpPr/>
         <p:nvPr/>
       </p:nvGrpSpPr>
-      <p:grpSpPr/>
+      <p:grpSpPr>
+        <a:xfrm>
+          <a:off x="0" y="0"/>
+          <a:ext cx="0" cy="0"/>
+          <a:chOff x="0" y="0"/>
+          <a:chExt cx="0" cy="0"/>
+        </a:xfrm>
+      </p:grpSpPr>
       <p:sp>
         <p:nvSpPr>
           <p:cNvPr id="2" name="Rectangle 1"/>
@@ -9694,6 +10077,7 @@
           <a:lstStyle/>
           <a:p>
             <a:pPr algn="ctr"/>
+            <a:endParaRPr/>
           </a:p>
         </p:txBody>
       </p:sp>
@@ -9803,7 +10187,7 @@
         </p:nvSpPr>
         <p:spPr>
           <a:xfrm>
-            <a:off x="365760" y="5650992"/>
+            <a:off x="365760" y="5879632"/>
             <a:ext cx="11457432" cy="594360"/>
           </a:xfrm>
           <a:prstGeom prst="rect">
@@ -9841,7 +10225,7 @@
 </file>
 
 <file path=ppt/slides/slide8.xml><?xml version="1.0" encoding="utf-8"?>
-<p:sld xmlns:a="http://schemas.openxmlformats.org/drawingml/2006/main" xmlns:p="http://schemas.openxmlformats.org/presentationml/2006/main" xmlns:r="http://schemas.openxmlformats.org/officeDocument/2006/relationships">
+<p:sld xmlns:a="http://schemas.openxmlformats.org/drawingml/2006/main" xmlns:r="http://schemas.openxmlformats.org/officeDocument/2006/relationships" xmlns:p="http://schemas.openxmlformats.org/presentationml/2006/main">
   <p:cSld>
     <p:bg>
       <p:bgPr>
@@ -9857,7 +10241,14 @@
         <p:cNvGrpSpPr/>
         <p:nvPr/>
       </p:nvGrpSpPr>
-      <p:grpSpPr/>
+      <p:grpSpPr>
+        <a:xfrm>
+          <a:off x="0" y="0"/>
+          <a:ext cx="0" cy="0"/>
+          <a:chOff x="0" y="0"/>
+          <a:chExt cx="0" cy="0"/>
+        </a:xfrm>
+      </p:grpSpPr>
       <p:sp>
         <p:nvSpPr>
           <p:cNvPr id="2" name="Rectangle 1"/>
@@ -9898,6 +10289,7 @@
           <a:lstStyle/>
           <a:p>
             <a:pPr algn="ctr"/>
+            <a:endParaRPr/>
           </a:p>
         </p:txBody>
       </p:sp>
@@ -10021,7 +10413,7 @@
 </file>
 
 <file path=ppt/slides/slide9.xml><?xml version="1.0" encoding="utf-8"?>
-<p:sld xmlns:a="http://schemas.openxmlformats.org/drawingml/2006/main" xmlns:p="http://schemas.openxmlformats.org/presentationml/2006/main" xmlns:r="http://schemas.openxmlformats.org/officeDocument/2006/relationships">
+<p:sld xmlns:a="http://schemas.openxmlformats.org/drawingml/2006/main" xmlns:r="http://schemas.openxmlformats.org/officeDocument/2006/relationships" xmlns:p="http://schemas.openxmlformats.org/presentationml/2006/main">
   <p:cSld>
     <p:spTree>
       <p:nvGrpSpPr>
@@ -10029,7 +10421,14 @@
         <p:cNvGrpSpPr/>
         <p:nvPr/>
       </p:nvGrpSpPr>
-      <p:grpSpPr/>
+      <p:grpSpPr>
+        <a:xfrm>
+          <a:off x="0" y="0"/>
+          <a:ext cx="0" cy="0"/>
+          <a:chOff x="0" y="0"/>
+          <a:chExt cx="0" cy="0"/>
+        </a:xfrm>
+      </p:grpSpPr>
       <p:sp>
         <p:nvSpPr>
           <p:cNvPr id="2" name="Rectangle 1"/>
@@ -10070,6 +10469,7 @@
           <a:lstStyle/>
           <a:p>
             <a:pPr algn="ctr"/>
+            <a:endParaRPr/>
           </a:p>
         </p:txBody>
       </p:sp>
@@ -10173,17 +10573,14 @@
                 <a:spcPts val="500"/>
               </a:spcBef>
             </a:pPr>
-            <a:r>
-              <a:rPr sz="1900">
-                <a:solidFill>
-                  <a:srgbClr val="374151"/>
-                </a:solidFill>
-                <a:latin typeface="微軟正黑體"/>
-                <a:ea typeface="微軟正黑體"/>
-                <a:cs typeface="微軟正黑體"/>
-              </a:rPr>
-              <a:t/>
-            </a:r>
+            <a:endParaRPr sz="1900">
+              <a:solidFill>
+                <a:srgbClr val="374151"/>
+              </a:solidFill>
+              <a:latin typeface="微軟正黑體"/>
+              <a:ea typeface="微軟正黑體"/>
+              <a:cs typeface="微軟正黑體"/>
+            </a:endParaRPr>
           </a:p>
           <a:p>
             <a:pPr algn="l">
@@ -10227,17 +10624,14 @@
                 <a:spcPts val="500"/>
               </a:spcBef>
             </a:pPr>
-            <a:r>
-              <a:rPr sz="1900">
-                <a:solidFill>
-                  <a:srgbClr val="374151"/>
-                </a:solidFill>
-                <a:latin typeface="微軟正黑體"/>
-                <a:ea typeface="微軟正黑體"/>
-                <a:cs typeface="微軟正黑體"/>
-              </a:rPr>
-              <a:t/>
-            </a:r>
+            <a:endParaRPr sz="1900">
+              <a:solidFill>
+                <a:srgbClr val="374151"/>
+              </a:solidFill>
+              <a:latin typeface="微軟正黑體"/>
+              <a:ea typeface="微軟正黑體"/>
+              <a:cs typeface="微軟正黑體"/>
+            </a:endParaRPr>
           </a:p>
           <a:p>
             <a:pPr algn="l">

</xml_diff>